<commit_message>
.\Python\Lesson 08 - Python Classes (OOP)"
</commit_message>
<xml_diff>
--- a/Python/Lesson 07 - Data Structures/Data Structures Basics.pptx
+++ b/Python/Lesson 07 - Data Structures/Data Structures Basics.pptx
@@ -223,7 +223,7 @@
           <a:p>
             <a:fld id="{941F8BC1-DC94-491B-AA44-0232F744EE98}" type="datetimeFigureOut">
               <a:rPr lang="en-US" smtClean="0"/>
-              <a:t>7/27/2026</a:t>
+              <a:t>7/29/2026</a:t>
             </a:fld>
             <a:endParaRPr lang="en-US"/>
           </a:p>
@@ -1325,6 +1325,244 @@
 </p:notes>
 </file>
 
+<file path=ppt/notesSlides/notesSlide7.xml><?xml version="1.0" encoding="utf-8"?>
+<p:notes xmlns:a="http://schemas.openxmlformats.org/drawingml/2006/main" xmlns:r="http://schemas.openxmlformats.org/officeDocument/2006/relationships" xmlns:p="http://schemas.openxmlformats.org/presentationml/2006/main">
+  <p:cSld>
+    <p:spTree>
+      <p:nvGrpSpPr>
+        <p:cNvPr id="1" name=""/>
+        <p:cNvGrpSpPr/>
+        <p:nvPr/>
+      </p:nvGrpSpPr>
+      <p:grpSpPr>
+        <a:xfrm>
+          <a:off x="0" y="0"/>
+          <a:ext cx="0" cy="0"/>
+          <a:chOff x="0" y="0"/>
+          <a:chExt cx="0" cy="0"/>
+        </a:xfrm>
+      </p:grpSpPr>
+      <p:sp>
+        <p:nvSpPr>
+          <p:cNvPr id="2" name="Slide Image Placeholder 1"/>
+          <p:cNvSpPr>
+            <a:spLocks noGrp="1" noRot="1" noChangeAspect="1"/>
+          </p:cNvSpPr>
+          <p:nvPr>
+            <p:ph type="sldImg"/>
+          </p:nvPr>
+        </p:nvSpPr>
+        <p:spPr/>
+      </p:sp>
+      <p:sp>
+        <p:nvSpPr>
+          <p:cNvPr id="3" name="Notes Placeholder 2"/>
+          <p:cNvSpPr>
+            <a:spLocks noGrp="1"/>
+          </p:cNvSpPr>
+          <p:nvPr>
+            <p:ph type="body" idx="1"/>
+          </p:nvPr>
+        </p:nvSpPr>
+        <p:spPr/>
+        <p:txBody>
+          <a:bodyPr/>
+          <a:lstStyle/>
+          <a:p>
+            <a:r>
+              <a:rPr lang="en-US" dirty="0"/>
+              <a:t>“Think of a phonebook!!” – Maj Shafer </a:t>
+            </a:r>
+          </a:p>
+          <a:p>
+            <a:endParaRPr lang="en-US" dirty="0"/>
+          </a:p>
+          <a:p>
+            <a:r>
+              <a:rPr lang="en-US" dirty="0"/>
+              <a:t>Key Value pairs </a:t>
+            </a:r>
+          </a:p>
+          <a:p>
+            <a:endParaRPr lang="en-US" dirty="0"/>
+          </a:p>
+          <a:p>
+            <a:endParaRPr lang="en-US" dirty="0"/>
+          </a:p>
+        </p:txBody>
+      </p:sp>
+      <p:sp>
+        <p:nvSpPr>
+          <p:cNvPr id="4" name="Slide Number Placeholder 3"/>
+          <p:cNvSpPr>
+            <a:spLocks noGrp="1"/>
+          </p:cNvSpPr>
+          <p:nvPr>
+            <p:ph type="sldNum" sz="quarter" idx="5"/>
+          </p:nvPr>
+        </p:nvSpPr>
+        <p:spPr/>
+        <p:txBody>
+          <a:bodyPr/>
+          <a:lstStyle/>
+          <a:p>
+            <a:fld id="{2D8B709C-82E0-4ADF-BDA3-CCA1C8B22229}" type="slidenum">
+              <a:rPr lang="en-US" smtClean="0"/>
+              <a:t>18</a:t>
+            </a:fld>
+            <a:endParaRPr lang="en-US"/>
+          </a:p>
+        </p:txBody>
+      </p:sp>
+    </p:spTree>
+    <p:extLst>
+      <p:ext uri="{BB962C8B-B14F-4D97-AF65-F5344CB8AC3E}">
+        <p14:creationId xmlns:p14="http://schemas.microsoft.com/office/powerpoint/2010/main" val="3459462577"/>
+      </p:ext>
+    </p:extLst>
+  </p:cSld>
+  <p:clrMapOvr>
+    <a:masterClrMapping/>
+  </p:clrMapOvr>
+</p:notes>
+</file>
+
+<file path=ppt/notesSlides/notesSlide8.xml><?xml version="1.0" encoding="utf-8"?>
+<p:notes xmlns:a="http://schemas.openxmlformats.org/drawingml/2006/main" xmlns:r="http://schemas.openxmlformats.org/officeDocument/2006/relationships" xmlns:p="http://schemas.openxmlformats.org/presentationml/2006/main">
+  <p:cSld>
+    <p:spTree>
+      <p:nvGrpSpPr>
+        <p:cNvPr id="1" name=""/>
+        <p:cNvGrpSpPr/>
+        <p:nvPr/>
+      </p:nvGrpSpPr>
+      <p:grpSpPr>
+        <a:xfrm>
+          <a:off x="0" y="0"/>
+          <a:ext cx="0" cy="0"/>
+          <a:chOff x="0" y="0"/>
+          <a:chExt cx="0" cy="0"/>
+        </a:xfrm>
+      </p:grpSpPr>
+      <p:sp>
+        <p:nvSpPr>
+          <p:cNvPr id="2" name="Slide Image Placeholder 1"/>
+          <p:cNvSpPr>
+            <a:spLocks noGrp="1" noRot="1" noChangeAspect="1"/>
+          </p:cNvSpPr>
+          <p:nvPr>
+            <p:ph type="sldImg"/>
+          </p:nvPr>
+        </p:nvSpPr>
+        <p:spPr/>
+      </p:sp>
+      <p:sp>
+        <p:nvSpPr>
+          <p:cNvPr id="3" name="Notes Placeholder 2"/>
+          <p:cNvSpPr>
+            <a:spLocks noGrp="1"/>
+          </p:cNvSpPr>
+          <p:nvPr>
+            <p:ph type="body" idx="1"/>
+          </p:nvPr>
+        </p:nvSpPr>
+        <p:spPr/>
+        <p:txBody>
+          <a:bodyPr/>
+          <a:lstStyle/>
+          <a:p>
+            <a:r>
+              <a:rPr lang="en-US" dirty="0"/>
+              <a:t>Sets: Collection of unique objects</a:t>
+            </a:r>
+          </a:p>
+          <a:p>
+            <a:endParaRPr lang="en-US" dirty="0"/>
+          </a:p>
+          <a:p>
+            <a:pPr marL="171450" indent="-171450">
+              <a:buFontTx/>
+              <a:buChar char="-"/>
+            </a:pPr>
+            <a:r>
+              <a:rPr lang="en-US" dirty="0"/>
+              <a:t>No order </a:t>
+            </a:r>
+          </a:p>
+          <a:p>
+            <a:pPr marL="171450" indent="-171450">
+              <a:buFontTx/>
+              <a:buChar char="-"/>
+            </a:pPr>
+            <a:r>
+              <a:rPr lang="en-US" dirty="0"/>
+              <a:t>Can add or remove </a:t>
+            </a:r>
+          </a:p>
+          <a:p>
+            <a:pPr marL="171450" indent="-171450">
+              <a:buFontTx/>
+              <a:buChar char="-"/>
+            </a:pPr>
+            <a:r>
+              <a:rPr lang="en-US" dirty="0"/>
+              <a:t>Can’t index. “There are just things in the set” Maj Shafer </a:t>
+            </a:r>
+          </a:p>
+          <a:p>
+            <a:pPr marL="171450" indent="-171450">
+              <a:buFontTx/>
+              <a:buChar char="-"/>
+            </a:pPr>
+            <a:r>
+              <a:rPr lang="en-US" dirty="0"/>
+              <a:t>(O(1)) – Looking at something in constant time </a:t>
+            </a:r>
+          </a:p>
+          <a:p>
+            <a:r>
+              <a:rPr lang="en-US" dirty="0"/>
+              <a:t>- Sets are faster when it comes to memberships</a:t>
+            </a:r>
+          </a:p>
+        </p:txBody>
+      </p:sp>
+      <p:sp>
+        <p:nvSpPr>
+          <p:cNvPr id="4" name="Slide Number Placeholder 3"/>
+          <p:cNvSpPr>
+            <a:spLocks noGrp="1"/>
+          </p:cNvSpPr>
+          <p:nvPr>
+            <p:ph type="sldNum" sz="quarter" idx="5"/>
+          </p:nvPr>
+        </p:nvSpPr>
+        <p:spPr/>
+        <p:txBody>
+          <a:bodyPr/>
+          <a:lstStyle/>
+          <a:p>
+            <a:fld id="{2D8B709C-82E0-4ADF-BDA3-CCA1C8B22229}" type="slidenum">
+              <a:rPr lang="en-US" smtClean="0"/>
+              <a:t>21</a:t>
+            </a:fld>
+            <a:endParaRPr lang="en-US"/>
+          </a:p>
+        </p:txBody>
+      </p:sp>
+    </p:spTree>
+    <p:extLst>
+      <p:ext uri="{BB962C8B-B14F-4D97-AF65-F5344CB8AC3E}">
+        <p14:creationId xmlns:p14="http://schemas.microsoft.com/office/powerpoint/2010/main" val="2193837005"/>
+      </p:ext>
+    </p:extLst>
+  </p:cSld>
+  <p:clrMapOvr>
+    <a:masterClrMapping/>
+  </p:clrMapOvr>
+</p:notes>
+</file>
+
 <file path=ppt/slideLayouts/slideLayout1.xml><?xml version="1.0" encoding="utf-8"?>
 <p:sldLayout xmlns:a="http://schemas.openxmlformats.org/drawingml/2006/main" xmlns:r="http://schemas.openxmlformats.org/officeDocument/2006/relationships" xmlns:p="http://schemas.openxmlformats.org/presentationml/2006/main" showMasterSp="0" preserve="1" userDrawn="1">
   <p:cSld name="Title Slide">
@@ -1373,7 +1611,7 @@
           <a:p>
             <a:fld id="{7A3E0868-4E26-4CDC-8A56-D70E2D8B12FE}" type="datetime3">
               <a:rPr lang="en-US" smtClean="0"/>
-              <a:t>27 July 2026</a:t>
+              <a:t>29 July 2026</a:t>
             </a:fld>
             <a:endParaRPr lang="en-US"/>
           </a:p>
@@ -3934,7 +4172,7 @@
           <a:p>
             <a:fld id="{A7B8021B-6105-4216-96FC-94348F216D0E}" type="datetime3">
               <a:rPr lang="en-US" smtClean="0"/>
-              <a:t>27 July 2026</a:t>
+              <a:t>29 July 2026</a:t>
             </a:fld>
             <a:endParaRPr lang="en-US"/>
           </a:p>
@@ -5631,7 +5869,7 @@
           <a:p>
             <a:fld id="{5D27CFAB-73E6-44A8-B862-B3306344E3F2}" type="datetime3">
               <a:rPr lang="en-US" smtClean="0"/>
-              <a:t>27 July 2026</a:t>
+              <a:t>29 July 2026</a:t>
             </a:fld>
             <a:endParaRPr lang="en-US"/>
           </a:p>
@@ -7421,7 +7659,7 @@
           <a:p>
             <a:fld id="{A9B2E784-A5F5-4301-881B-94AC8DBF9DED}" type="datetime3">
               <a:rPr lang="en-US" smtClean="0"/>
-              <a:t>27 July 2026</a:t>
+              <a:t>29 July 2026</a:t>
             </a:fld>
             <a:endParaRPr lang="en-US"/>
           </a:p>
@@ -7600,7 +7838,7 @@
           <a:p>
             <a:fld id="{18EAB3A5-9E92-4BB9-8F22-9632B4FBEDBA}" type="datetime3">
               <a:rPr lang="en-US" smtClean="0"/>
-              <a:t>27 July 2026</a:t>
+              <a:t>29 July 2026</a:t>
             </a:fld>
             <a:endParaRPr lang="en-US"/>
           </a:p>
@@ -7827,7 +8065,7 @@
           <a:p>
             <a:fld id="{40923810-5FB2-48C9-96CA-1DE2C4773142}" type="datetime3">
               <a:rPr lang="en-US" smtClean="0"/>
-              <a:t>27 July 2026</a:t>
+              <a:t>29 July 2026</a:t>
             </a:fld>
             <a:endParaRPr lang="en-US"/>
           </a:p>
@@ -8117,7 +8355,7 @@
           <a:p>
             <a:fld id="{E50EFF4B-86EB-42FB-93EA-7D8F9CB2466F}" type="datetime3">
               <a:rPr lang="en-US" smtClean="0"/>
-              <a:t>27 July 2026</a:t>
+              <a:t>29 July 2026</a:t>
             </a:fld>
             <a:endParaRPr lang="en-US"/>
           </a:p>
@@ -8729,7 +8967,7 @@
           <a:p>
             <a:fld id="{FB14FC24-E041-45E9-9A72-E5755A86890F}" type="datetime3">
               <a:rPr lang="en-US" smtClean="0"/>
-              <a:t>27 July 2026</a:t>
+              <a:t>29 July 2026</a:t>
             </a:fld>
             <a:endParaRPr lang="en-US"/>
           </a:p>
@@ -9589,7 +9827,7 @@
           <a:p>
             <a:fld id="{98A19125-94A7-4474-858C-FD9C4ABE9DDA}" type="datetime3">
               <a:rPr lang="en-US" smtClean="0"/>
-              <a:t>27 July 2026</a:t>
+              <a:t>29 July 2026</a:t>
             </a:fld>
             <a:endParaRPr lang="en-US"/>
           </a:p>
@@ -10692,7 +10930,7 @@
           <a:p>
             <a:fld id="{3BA0343D-C8D8-43CE-BB79-50DEA219DB07}" type="datetime3">
               <a:rPr lang="en-US" smtClean="0"/>
-              <a:t>27 July 2026</a:t>
+              <a:t>29 July 2026</a:t>
             </a:fld>
             <a:endParaRPr lang="en-US"/>
           </a:p>
@@ -10981,7 +11219,7 @@
           <a:p>
             <a:fld id="{453BD212-0B9F-4987-965F-AC83B2FC354F}" type="datetime3">
               <a:rPr lang="en-US" smtClean="0"/>
-              <a:t>27 July 2026</a:t>
+              <a:t>29 July 2026</a:t>
             </a:fld>
             <a:endParaRPr lang="en-US"/>
           </a:p>
@@ -11224,7 +11462,7 @@
           <a:p>
             <a:fld id="{6DDC931E-8CBE-4A3F-A034-9B6122C6DCDB}" type="datetime3">
               <a:rPr lang="en-US" smtClean="0"/>
-              <a:t>27 July 2026</a:t>
+              <a:t>29 July 2026</a:t>
             </a:fld>
             <a:endParaRPr lang="en-US"/>
           </a:p>
@@ -12990,7 +13228,7 @@
           <a:p>
             <a:fld id="{220AF9C2-5E8A-4308-AE6B-CA9B65007D0E}" type="datetime3">
               <a:rPr lang="en-US" smtClean="0"/>
-              <a:t>27 July 2026</a:t>
+              <a:t>29 July 2026</a:t>
             </a:fld>
             <a:endParaRPr lang="en-US"/>
           </a:p>
@@ -13303,7 +13541,7 @@
           <a:p>
             <a:fld id="{FF31E861-D2AF-431D-860B-DCF67C218052}" type="datetime3">
               <a:rPr lang="en-US" smtClean="0"/>
-              <a:t>27 July 2026</a:t>
+              <a:t>29 July 2026</a:t>
             </a:fld>
             <a:endParaRPr lang="en-US"/>
           </a:p>
@@ -13582,7 +13820,7 @@
           <a:p>
             <a:fld id="{D1DA25B2-AAF1-4C1F-AA38-12D5BFA7D4C8}" type="datetime3">
               <a:rPr lang="en-US" smtClean="0"/>
-              <a:t>27 July 2026</a:t>
+              <a:t>29 July 2026</a:t>
             </a:fld>
             <a:endParaRPr lang="en-US"/>
           </a:p>
@@ -13861,7 +14099,7 @@
           <a:p>
             <a:fld id="{A25C0F39-45D0-48E9-90B3-7FE8FCE561C8}" type="datetime3">
               <a:rPr lang="en-US" smtClean="0"/>
-              <a:t>27 July 2026</a:t>
+              <a:t>29 July 2026</a:t>
             </a:fld>
             <a:endParaRPr lang="en-US"/>
           </a:p>
@@ -14362,7 +14600,7 @@
           <a:p>
             <a:fld id="{9BAF1A3D-92FA-4F24-9781-74AFA516A230}" type="datetime3">
               <a:rPr lang="en-US" smtClean="0"/>
-              <a:t>27 July 2026</a:t>
+              <a:t>29 July 2026</a:t>
             </a:fld>
             <a:endParaRPr lang="en-US"/>
           </a:p>
@@ -14489,7 +14727,7 @@
           <a:p>
             <a:fld id="{5719C672-856D-4617-A693-8FE15749A9B7}" type="datetime3">
               <a:rPr lang="en-US" smtClean="0"/>
-              <a:t>27 July 2026</a:t>
+              <a:t>29 July 2026</a:t>
             </a:fld>
             <a:endParaRPr lang="en-US"/>
           </a:p>
@@ -14624,7 +14862,7 @@
           <a:p>
             <a:fld id="{5F6C764D-A39E-4C03-B161-E0BC66E8883B}" type="datetime3">
               <a:rPr lang="en-US" smtClean="0"/>
-              <a:t>27 July 2026</a:t>
+              <a:t>29 July 2026</a:t>
             </a:fld>
             <a:endParaRPr lang="en-US"/>
           </a:p>
@@ -14862,7 +15100,7 @@
           <a:p>
             <a:fld id="{6E3E33F9-20B7-4995-BE7D-165DBB597850}" type="datetime3">
               <a:rPr lang="en-US" smtClean="0"/>
-              <a:t>27 July 2026</a:t>
+              <a:t>29 July 2026</a:t>
             </a:fld>
             <a:endParaRPr lang="en-US"/>
           </a:p>
@@ -14975,7 +15213,7 @@
           <a:p>
             <a:fld id="{CD41C263-3501-4369-A962-62B6BF915CDE}" type="datetime3">
               <a:rPr lang="en-US" smtClean="0"/>
-              <a:t>27 July 2026</a:t>
+              <a:t>29 July 2026</a:t>
             </a:fld>
             <a:endParaRPr lang="en-US"/>
           </a:p>
@@ -15378,7 +15616,7 @@
           <a:p>
             <a:fld id="{B06F3EBE-B2E8-4992-9F00-9E4B44F057C0}" type="datetime3">
               <a:rPr lang="en-US" smtClean="0"/>
-              <a:t>27 July 2026</a:t>
+              <a:t>29 July 2026</a:t>
             </a:fld>
             <a:endParaRPr lang="en-US"/>
           </a:p>
@@ -15510,7 +15748,7 @@
           <a:p>
             <a:fld id="{D41656AB-D2E1-472E-8B95-0DF5C6E1D623}" type="datetime3">
               <a:rPr lang="en-US" smtClean="0"/>
-              <a:t>27 July 2026</a:t>
+              <a:t>29 July 2026</a:t>
             </a:fld>
             <a:endParaRPr lang="en-US"/>
           </a:p>
@@ -17395,7 +17633,7 @@
           <a:p>
             <a:fld id="{971AFA9C-17DA-4726-B9E3-ADECF7729AF7}" type="datetimeFigureOut">
               <a:rPr lang="en-US" smtClean="0"/>
-              <a:t>7/27/2026</a:t>
+              <a:t>7/29/2026</a:t>
             </a:fld>
             <a:endParaRPr lang="en-US"/>
           </a:p>
@@ -17706,7 +17944,7 @@
           <a:p>
             <a:fld id="{971AFA9C-17DA-4726-B9E3-ADECF7729AF7}" type="datetimeFigureOut">
               <a:rPr lang="en-US" smtClean="0"/>
-              <a:t>7/27/2026</a:t>
+              <a:t>7/29/2026</a:t>
             </a:fld>
             <a:endParaRPr lang="en-US"/>
           </a:p>
@@ -18623,7 +18861,7 @@
           <a:p>
             <a:fld id="{AD622D1A-DF83-41A8-85FF-04D90BF831D3}" type="datetime3">
               <a:rPr lang="en-US" smtClean="0"/>
-              <a:t>27 July 2026</a:t>
+              <a:t>29 July 2026</a:t>
             </a:fld>
             <a:endParaRPr lang="en-US"/>
           </a:p>
@@ -18873,7 +19111,7 @@
           <a:p>
             <a:fld id="{334F72C3-CDF3-44A8-B602-1649B1728485}" type="datetime3">
               <a:rPr lang="en-US" smtClean="0"/>
-              <a:t>27 July 2026</a:t>
+              <a:t>29 July 2026</a:t>
             </a:fld>
             <a:endParaRPr lang="en-US"/>
           </a:p>
@@ -19180,7 +19418,7 @@
           <a:p>
             <a:fld id="{1E0132BA-B5E7-4FFD-AF6C-169169D47D4A}" type="datetime3">
               <a:rPr lang="en-US" smtClean="0"/>
-              <a:t>27 July 2026</a:t>
+              <a:t>29 July 2026</a:t>
             </a:fld>
             <a:endParaRPr lang="en-US"/>
           </a:p>
@@ -19661,7 +19899,7 @@
           <a:p>
             <a:fld id="{81A30091-1C2A-4151-8D3C-D1E47A72615F}" type="datetime3">
               <a:rPr lang="en-US" smtClean="0"/>
-              <a:t>27 July 2026</a:t>
+              <a:t>29 July 2026</a:t>
             </a:fld>
             <a:endParaRPr lang="en-US"/>
           </a:p>
@@ -20298,7 +20536,7 @@
           <a:p>
             <a:fld id="{35D703CE-07B4-4C05-A488-B4566700621F}" type="datetime3">
               <a:rPr lang="en-US" smtClean="0"/>
-              <a:t>27 July 2026</a:t>
+              <a:t>29 July 2026</a:t>
             </a:fld>
             <a:endParaRPr lang="en-US"/>
           </a:p>
@@ -21356,7 +21594,7 @@
           <a:p>
             <a:fld id="{694BD61C-20BA-43AF-A21F-1DAFB3200099}" type="datetime3">
               <a:rPr lang="en-US" smtClean="0"/>
-              <a:t>27 July 2026</a:t>
+              <a:t>29 July 2026</a:t>
             </a:fld>
             <a:endParaRPr lang="en-US"/>
           </a:p>
@@ -21843,7 +22081,7 @@
           <a:p>
             <a:fld id="{CABCB1B0-B6E5-4DD1-BB55-95C076D6C0C8}" type="datetime3">
               <a:rPr lang="en-US" smtClean="0"/>
-              <a:t>27 July 2026</a:t>
+              <a:t>29 July 2026</a:t>
             </a:fld>
             <a:endParaRPr lang="en-US"/>
           </a:p>

</xml_diff>